<commit_message>
Temperature Validation + Figure Legend/Caption Updates
</commit_message>
<xml_diff>
--- a/Data/Figures/Fig4_Combined.pptx
+++ b/Data/Figures/Fig4_Combined.pptx
@@ -5,9 +5,9 @@
     <p:sldMasterId id="2147483648" r:id="rId1"/>
   </p:sldMasterIdLst>
   <p:sldIdLst>
-    <p:sldId id="256" r:id="rId2"/>
-    <p:sldId id="259" r:id="rId3"/>
-    <p:sldId id="260" r:id="rId4"/>
+    <p:sldId id="260" r:id="rId2"/>
+    <p:sldId id="256" r:id="rId3"/>
+    <p:sldId id="259" r:id="rId4"/>
   </p:sldIdLst>
   <p:sldSz cx="12192000" cy="6858000"/>
   <p:notesSz cx="6858000" cy="9144000"/>
@@ -114,25 +114,17 @@
 </p:presentation>
 </file>
 
-<file path=ppt/revisionInfo.xml><?xml version="1.0" encoding="utf-8"?>
-<p1510:revInfo xmlns:a="http://schemas.openxmlformats.org/drawingml/2006/main" xmlns:r="http://schemas.openxmlformats.org/officeDocument/2006/relationships" xmlns:p1510="http://schemas.microsoft.com/office/powerpoint/2015/10/main">
-  <p1510:revLst>
-    <p1510:client id="{9BFD2F3C-2179-4C47-9759-1E5755FAE0D7}" v="1" dt="2026-03-17T16:33:44.606"/>
-  </p1510:revLst>
-</p1510:revInfo>
-</file>
-
 <file path=ppt/changesInfos/changesInfo1.xml><?xml version="1.0" encoding="utf-8"?>
 <pc:chgInfo xmlns:a="http://schemas.openxmlformats.org/drawingml/2006/main" xmlns:r="http://schemas.openxmlformats.org/officeDocument/2006/relationships" xmlns:ac="http://schemas.microsoft.com/office/drawing/2013/main/command" xmlns:pc="http://schemas.microsoft.com/office/powerpoint/2013/main/command">
   <pc:docChgLst>
     <pc:chgData name="Burley, Katherine Lane" userId="3eb27e8d-939c-4a6c-b9cc-42a246f42731" providerId="ADAL" clId="{763BCDF5-EDBC-47C4-83CD-DAA3DF0A80B6}"/>
-    <pc:docChg chg="undo custSel addSld delSld modSld">
-      <pc:chgData name="Burley, Katherine Lane" userId="3eb27e8d-939c-4a6c-b9cc-42a246f42731" providerId="ADAL" clId="{763BCDF5-EDBC-47C4-83CD-DAA3DF0A80B6}" dt="2026-03-17T16:34:58.225" v="77" actId="14100"/>
+    <pc:docChg chg="undo custSel addSld delSld modSld sldOrd">
+      <pc:chgData name="Burley, Katherine Lane" userId="3eb27e8d-939c-4a6c-b9cc-42a246f42731" providerId="ADAL" clId="{763BCDF5-EDBC-47C4-83CD-DAA3DF0A80B6}" dt="2026-03-26T14:07:56.108" v="79"/>
       <pc:docMkLst>
         <pc:docMk/>
       </pc:docMkLst>
-      <pc:sldChg chg="addSp delSp modSp add mod">
-        <pc:chgData name="Burley, Katherine Lane" userId="3eb27e8d-939c-4a6c-b9cc-42a246f42731" providerId="ADAL" clId="{763BCDF5-EDBC-47C4-83CD-DAA3DF0A80B6}" dt="2026-03-17T16:34:58.225" v="77" actId="14100"/>
+      <pc:sldChg chg="addSp delSp modSp add mod ord">
+        <pc:chgData name="Burley, Katherine Lane" userId="3eb27e8d-939c-4a6c-b9cc-42a246f42731" providerId="ADAL" clId="{763BCDF5-EDBC-47C4-83CD-DAA3DF0A80B6}" dt="2026-03-26T14:07:56.108" v="79"/>
         <pc:sldMkLst>
           <pc:docMk/>
           <pc:sldMk cId="4158832961" sldId="260"/>
@@ -151,14 +143,6 @@
             <pc:docMk/>
             <pc:sldMk cId="4158832961" sldId="260"/>
             <ac:picMk id="4" creationId="{91142877-F442-E221-B2D8-631D93D33AE1}"/>
-          </ac:picMkLst>
-        </pc:picChg>
-        <pc:picChg chg="del">
-          <ac:chgData name="Burley, Katherine Lane" userId="3eb27e8d-939c-4a6c-b9cc-42a246f42731" providerId="ADAL" clId="{763BCDF5-EDBC-47C4-83CD-DAA3DF0A80B6}" dt="2026-03-17T16:33:48.353" v="66" actId="478"/>
-          <ac:picMkLst>
-            <pc:docMk/>
-            <pc:sldMk cId="4158832961" sldId="260"/>
-            <ac:picMk id="7" creationId="{41B88D2B-C8CD-7730-495E-4C36C59CD631}"/>
           </ac:picMkLst>
         </pc:picChg>
       </pc:sldChg>
@@ -314,7 +298,7 @@
           <a:p>
             <a:fld id="{AD9D11BD-181B-4417-BBD5-014D2FD346EF}" type="datetimeFigureOut">
               <a:rPr lang="en-US" smtClean="0"/>
-              <a:t>3/17/2026</a:t>
+              <a:t>3/26/2026</a:t>
             </a:fld>
             <a:endParaRPr lang="en-US"/>
           </a:p>
@@ -512,7 +496,7 @@
           <a:p>
             <a:fld id="{AD9D11BD-181B-4417-BBD5-014D2FD346EF}" type="datetimeFigureOut">
               <a:rPr lang="en-US" smtClean="0"/>
-              <a:t>3/17/2026</a:t>
+              <a:t>3/26/2026</a:t>
             </a:fld>
             <a:endParaRPr lang="en-US"/>
           </a:p>
@@ -720,7 +704,7 @@
           <a:p>
             <a:fld id="{AD9D11BD-181B-4417-BBD5-014D2FD346EF}" type="datetimeFigureOut">
               <a:rPr lang="en-US" smtClean="0"/>
-              <a:t>3/17/2026</a:t>
+              <a:t>3/26/2026</a:t>
             </a:fld>
             <a:endParaRPr lang="en-US"/>
           </a:p>
@@ -918,7 +902,7 @@
           <a:p>
             <a:fld id="{AD9D11BD-181B-4417-BBD5-014D2FD346EF}" type="datetimeFigureOut">
               <a:rPr lang="en-US" smtClean="0"/>
-              <a:t>3/17/2026</a:t>
+              <a:t>3/26/2026</a:t>
             </a:fld>
             <a:endParaRPr lang="en-US"/>
           </a:p>
@@ -1193,7 +1177,7 @@
           <a:p>
             <a:fld id="{AD9D11BD-181B-4417-BBD5-014D2FD346EF}" type="datetimeFigureOut">
               <a:rPr lang="en-US" smtClean="0"/>
-              <a:t>3/17/2026</a:t>
+              <a:t>3/26/2026</a:t>
             </a:fld>
             <a:endParaRPr lang="en-US"/>
           </a:p>
@@ -1458,7 +1442,7 @@
           <a:p>
             <a:fld id="{AD9D11BD-181B-4417-BBD5-014D2FD346EF}" type="datetimeFigureOut">
               <a:rPr lang="en-US" smtClean="0"/>
-              <a:t>3/17/2026</a:t>
+              <a:t>3/26/2026</a:t>
             </a:fld>
             <a:endParaRPr lang="en-US"/>
           </a:p>
@@ -1870,7 +1854,7 @@
           <a:p>
             <a:fld id="{AD9D11BD-181B-4417-BBD5-014D2FD346EF}" type="datetimeFigureOut">
               <a:rPr lang="en-US" smtClean="0"/>
-              <a:t>3/17/2026</a:t>
+              <a:t>3/26/2026</a:t>
             </a:fld>
             <a:endParaRPr lang="en-US"/>
           </a:p>
@@ -2011,7 +1995,7 @@
           <a:p>
             <a:fld id="{AD9D11BD-181B-4417-BBD5-014D2FD346EF}" type="datetimeFigureOut">
               <a:rPr lang="en-US" smtClean="0"/>
-              <a:t>3/17/2026</a:t>
+              <a:t>3/26/2026</a:t>
             </a:fld>
             <a:endParaRPr lang="en-US"/>
           </a:p>
@@ -2124,7 +2108,7 @@
           <a:p>
             <a:fld id="{AD9D11BD-181B-4417-BBD5-014D2FD346EF}" type="datetimeFigureOut">
               <a:rPr lang="en-US" smtClean="0"/>
-              <a:t>3/17/2026</a:t>
+              <a:t>3/26/2026</a:t>
             </a:fld>
             <a:endParaRPr lang="en-US"/>
           </a:p>
@@ -2435,7 +2419,7 @@
           <a:p>
             <a:fld id="{AD9D11BD-181B-4417-BBD5-014D2FD346EF}" type="datetimeFigureOut">
               <a:rPr lang="en-US" smtClean="0"/>
-              <a:t>3/17/2026</a:t>
+              <a:t>3/26/2026</a:t>
             </a:fld>
             <a:endParaRPr lang="en-US"/>
           </a:p>
@@ -2723,7 +2707,7 @@
           <a:p>
             <a:fld id="{AD9D11BD-181B-4417-BBD5-014D2FD346EF}" type="datetimeFigureOut">
               <a:rPr lang="en-US" smtClean="0"/>
-              <a:t>3/17/2026</a:t>
+              <a:t>3/26/2026</a:t>
             </a:fld>
             <a:endParaRPr lang="en-US"/>
           </a:p>
@@ -2964,7 +2948,7 @@
           <a:p>
             <a:fld id="{AD9D11BD-181B-4417-BBD5-014D2FD346EF}" type="datetimeFigureOut">
               <a:rPr lang="en-US" smtClean="0"/>
-              <a:t>3/17/2026</a:t>
+              <a:t>3/26/2026</a:t>
             </a:fld>
             <a:endParaRPr lang="en-US"/>
           </a:p>
@@ -3369,6 +3353,109 @@
   <p:cSld>
     <p:spTree>
       <p:nvGrpSpPr>
+        <p:cNvPr id="1" name="">
+          <a:extLst>
+            <a:ext uri="{FF2B5EF4-FFF2-40B4-BE49-F238E27FC236}">
+              <a16:creationId xmlns:a16="http://schemas.microsoft.com/office/drawing/2014/main" id="{8A12AED5-1A91-1AC9-35ED-34DF88D721D5}"/>
+            </a:ext>
+          </a:extLst>
+        </p:cNvPr>
+        <p:cNvGrpSpPr/>
+        <p:nvPr/>
+      </p:nvGrpSpPr>
+      <p:grpSpPr>
+        <a:xfrm>
+          <a:off x="0" y="0"/>
+          <a:ext cx="0" cy="0"/>
+          <a:chOff x="0" y="0"/>
+          <a:chExt cx="0" cy="0"/>
+        </a:xfrm>
+      </p:grpSpPr>
+      <p:pic>
+        <p:nvPicPr>
+          <p:cNvPr id="3" name="Picture 2" descr="A screenshot of a computer generated image&#10;&#10;AI-generated content may be incorrect.">
+            <a:extLst>
+              <a:ext uri="{FF2B5EF4-FFF2-40B4-BE49-F238E27FC236}">
+                <a16:creationId xmlns:a16="http://schemas.microsoft.com/office/drawing/2014/main" id="{5C0AC0E6-3B04-D372-212A-455FB9509F69}"/>
+              </a:ext>
+            </a:extLst>
+          </p:cNvPr>
+          <p:cNvPicPr>
+            <a:picLocks noChangeAspect="1"/>
+          </p:cNvPicPr>
+          <p:nvPr/>
+        </p:nvPicPr>
+        <p:blipFill>
+          <a:blip r:embed="rId2">
+            <a:extLst>
+              <a:ext uri="{28A0092B-C50C-407E-A947-70E740481C1C}">
+                <a14:useLocalDpi xmlns:a14="http://schemas.microsoft.com/office/drawing/2010/main" val="0"/>
+              </a:ext>
+            </a:extLst>
+          </a:blip>
+          <a:stretch>
+            <a:fillRect/>
+          </a:stretch>
+        </p:blipFill>
+        <p:spPr>
+          <a:xfrm>
+            <a:off x="55420" y="100485"/>
+            <a:ext cx="12136580" cy="6068290"/>
+          </a:xfrm>
+          <a:prstGeom prst="rect">
+            <a:avLst/>
+          </a:prstGeom>
+        </p:spPr>
+      </p:pic>
+      <p:pic>
+        <p:nvPicPr>
+          <p:cNvPr id="4" name="Picture 3">
+            <a:extLst>
+              <a:ext uri="{FF2B5EF4-FFF2-40B4-BE49-F238E27FC236}">
+                <a16:creationId xmlns:a16="http://schemas.microsoft.com/office/drawing/2014/main" id="{91142877-F442-E221-B2D8-631D93D33AE1}"/>
+              </a:ext>
+            </a:extLst>
+          </p:cNvPr>
+          <p:cNvPicPr>
+            <a:picLocks noChangeAspect="1"/>
+          </p:cNvPicPr>
+          <p:nvPr/>
+        </p:nvPicPr>
+        <p:blipFill>
+          <a:blip r:embed="rId3"/>
+          <a:srcRect t="1903"/>
+          <a:stretch>
+            <a:fillRect/>
+          </a:stretch>
+        </p:blipFill>
+        <p:spPr>
+          <a:xfrm>
+            <a:off x="55421" y="4552334"/>
+            <a:ext cx="2371589" cy="2281247"/>
+          </a:xfrm>
+          <a:prstGeom prst="rect">
+            <a:avLst/>
+          </a:prstGeom>
+        </p:spPr>
+      </p:pic>
+    </p:spTree>
+    <p:extLst>
+      <p:ext uri="{BB962C8B-B14F-4D97-AF65-F5344CB8AC3E}">
+        <p14:creationId xmlns:p14="http://schemas.microsoft.com/office/powerpoint/2010/main" val="4158832961"/>
+      </p:ext>
+    </p:extLst>
+  </p:cSld>
+  <p:clrMapOvr>
+    <a:masterClrMapping/>
+  </p:clrMapOvr>
+</p:sld>
+</file>
+
+<file path=ppt/slides/slide2.xml><?xml version="1.0" encoding="utf-8"?>
+<p:sld xmlns:a="http://schemas.openxmlformats.org/drawingml/2006/main" xmlns:r="http://schemas.openxmlformats.org/officeDocument/2006/relationships" xmlns:p="http://schemas.openxmlformats.org/presentationml/2006/main">
+  <p:cSld>
+    <p:spTree>
+      <p:nvGrpSpPr>
         <p:cNvPr id="1" name=""/>
         <p:cNvGrpSpPr/>
         <p:nvPr/>
@@ -3504,7 +3591,7 @@
 </p:sld>
 </file>
 
-<file path=ppt/slides/slide2.xml><?xml version="1.0" encoding="utf-8"?>
+<file path=ppt/slides/slide3.xml><?xml version="1.0" encoding="utf-8"?>
 <p:sld xmlns:a="http://schemas.openxmlformats.org/drawingml/2006/main" xmlns:r="http://schemas.openxmlformats.org/officeDocument/2006/relationships" xmlns:p="http://schemas.openxmlformats.org/presentationml/2006/main">
   <p:cSld>
     <p:spTree>
@@ -3604,109 +3691,6 @@
     <p:extLst>
       <p:ext uri="{BB962C8B-B14F-4D97-AF65-F5344CB8AC3E}">
         <p14:creationId xmlns:p14="http://schemas.microsoft.com/office/powerpoint/2010/main" val="3166697526"/>
-      </p:ext>
-    </p:extLst>
-  </p:cSld>
-  <p:clrMapOvr>
-    <a:masterClrMapping/>
-  </p:clrMapOvr>
-</p:sld>
-</file>
-
-<file path=ppt/slides/slide3.xml><?xml version="1.0" encoding="utf-8"?>
-<p:sld xmlns:a="http://schemas.openxmlformats.org/drawingml/2006/main" xmlns:r="http://schemas.openxmlformats.org/officeDocument/2006/relationships" xmlns:p="http://schemas.openxmlformats.org/presentationml/2006/main">
-  <p:cSld>
-    <p:spTree>
-      <p:nvGrpSpPr>
-        <p:cNvPr id="1" name="">
-          <a:extLst>
-            <a:ext uri="{FF2B5EF4-FFF2-40B4-BE49-F238E27FC236}">
-              <a16:creationId xmlns:a16="http://schemas.microsoft.com/office/drawing/2014/main" id="{8A12AED5-1A91-1AC9-35ED-34DF88D721D5}"/>
-            </a:ext>
-          </a:extLst>
-        </p:cNvPr>
-        <p:cNvGrpSpPr/>
-        <p:nvPr/>
-      </p:nvGrpSpPr>
-      <p:grpSpPr>
-        <a:xfrm>
-          <a:off x="0" y="0"/>
-          <a:ext cx="0" cy="0"/>
-          <a:chOff x="0" y="0"/>
-          <a:chExt cx="0" cy="0"/>
-        </a:xfrm>
-      </p:grpSpPr>
-      <p:pic>
-        <p:nvPicPr>
-          <p:cNvPr id="3" name="Picture 2" descr="A screenshot of a computer generated image&#10;&#10;AI-generated content may be incorrect.">
-            <a:extLst>
-              <a:ext uri="{FF2B5EF4-FFF2-40B4-BE49-F238E27FC236}">
-                <a16:creationId xmlns:a16="http://schemas.microsoft.com/office/drawing/2014/main" id="{5C0AC0E6-3B04-D372-212A-455FB9509F69}"/>
-              </a:ext>
-            </a:extLst>
-          </p:cNvPr>
-          <p:cNvPicPr>
-            <a:picLocks noChangeAspect="1"/>
-          </p:cNvPicPr>
-          <p:nvPr/>
-        </p:nvPicPr>
-        <p:blipFill>
-          <a:blip r:embed="rId2">
-            <a:extLst>
-              <a:ext uri="{28A0092B-C50C-407E-A947-70E740481C1C}">
-                <a14:useLocalDpi xmlns:a14="http://schemas.microsoft.com/office/drawing/2010/main" val="0"/>
-              </a:ext>
-            </a:extLst>
-          </a:blip>
-          <a:stretch>
-            <a:fillRect/>
-          </a:stretch>
-        </p:blipFill>
-        <p:spPr>
-          <a:xfrm>
-            <a:off x="55420" y="100485"/>
-            <a:ext cx="12136580" cy="6068290"/>
-          </a:xfrm>
-          <a:prstGeom prst="rect">
-            <a:avLst/>
-          </a:prstGeom>
-        </p:spPr>
-      </p:pic>
-      <p:pic>
-        <p:nvPicPr>
-          <p:cNvPr id="4" name="Picture 3">
-            <a:extLst>
-              <a:ext uri="{FF2B5EF4-FFF2-40B4-BE49-F238E27FC236}">
-                <a16:creationId xmlns:a16="http://schemas.microsoft.com/office/drawing/2014/main" id="{91142877-F442-E221-B2D8-631D93D33AE1}"/>
-              </a:ext>
-            </a:extLst>
-          </p:cNvPr>
-          <p:cNvPicPr>
-            <a:picLocks noChangeAspect="1"/>
-          </p:cNvPicPr>
-          <p:nvPr/>
-        </p:nvPicPr>
-        <p:blipFill>
-          <a:blip r:embed="rId3"/>
-          <a:srcRect t="1903"/>
-          <a:stretch>
-            <a:fillRect/>
-          </a:stretch>
-        </p:blipFill>
-        <p:spPr>
-          <a:xfrm>
-            <a:off x="55421" y="4552334"/>
-            <a:ext cx="2371589" cy="2281247"/>
-          </a:xfrm>
-          <a:prstGeom prst="rect">
-            <a:avLst/>
-          </a:prstGeom>
-        </p:spPr>
-      </p:pic>
-    </p:spTree>
-    <p:extLst>
-      <p:ext uri="{BB962C8B-B14F-4D97-AF65-F5344CB8AC3E}">
-        <p14:creationId xmlns:p14="http://schemas.microsoft.com/office/powerpoint/2010/main" val="4158832961"/>
       </p:ext>
     </p:extLst>
   </p:cSld>

</xml_diff>